<commit_message>
multilingual and ppt fixes
</commit_message>
<xml_diff>
--- a/docs/PPT/TERRAGRID _ AI Builder Cup.pptx
+++ b/docs/PPT/TERRAGRID _ AI Builder Cup.pptx
@@ -30,26 +30,19 @@
   <p:notesSz cx="6858000" cy="9144000"/>
   <p:embeddedFontLst>
     <p:embeddedFont>
-      <p:font typeface="Consolas" panose="020B0609020204030204" pitchFamily="49" charset="0"/>
+      <p:font typeface="Google Sans Flex" panose="020B0604020202020204" charset="0"/>
       <p:regular r:id="rId20"/>
       <p:bold r:id="rId21"/>
-      <p:italic r:id="rId22"/>
-      <p:boldItalic r:id="rId23"/>
-    </p:embeddedFont>
-    <p:embeddedFont>
-      <p:font typeface="Google Sans Flex" panose="020B0604020202020204" charset="0"/>
-      <p:regular r:id="rId24"/>
-      <p:bold r:id="rId25"/>
     </p:embeddedFont>
     <p:embeddedFont>
       <p:font typeface="Google Sans Flex Medium" panose="020B0604020202020204" charset="0"/>
-      <p:regular r:id="rId26"/>
-      <p:bold r:id="rId27"/>
+      <p:regular r:id="rId22"/>
+      <p:bold r:id="rId23"/>
     </p:embeddedFont>
     <p:embeddedFont>
       <p:font typeface="Google Sans Flex SemiBold" panose="020B0604020202020204" charset="0"/>
-      <p:regular r:id="rId28"/>
-      <p:bold r:id="rId29"/>
+      <p:regular r:id="rId24"/>
+      <p:bold r:id="rId25"/>
     </p:embeddedFont>
   </p:embeddedFontLst>
   <p:defaultTextStyle>
@@ -9664,7 +9657,7 @@
         <p:spPr>
           <a:xfrm>
             <a:off x="317602" y="578917"/>
-            <a:ext cx="8943000" cy="2050000"/>
+            <a:ext cx="8943000" cy="1385019"/>
           </a:xfrm>
           <a:prstGeom prst="rect">
             <a:avLst/>
@@ -9691,7 +9684,7 @@
               <a:buNone/>
             </a:pPr>
             <a:r>
-              <a:rPr sz="1300" b="0" i="0">
+              <a:rPr sz="1300" b="0" i="0" dirty="0">
                 <a:solidFill>
                   <a:srgbClr val="1A1A1A"/>
                 </a:solidFill>
@@ -9716,7 +9709,7 @@
               </a:spcAft>
             </a:pPr>
             <a:r>
-              <a:rPr sz="1050" b="1" i="0">
+              <a:rPr sz="1050" b="1" i="0" dirty="0">
                 <a:solidFill>
                   <a:srgbClr val="1A1A1A"/>
                 </a:solidFill>
@@ -9735,7 +9728,7 @@
               </a:spcAft>
             </a:pPr>
             <a:r>
-              <a:rPr sz="900" b="0" i="0">
+              <a:rPr sz="900" b="0" i="0" dirty="0">
                 <a:solidFill>
                   <a:srgbClr val="1A1A1A"/>
                 </a:solidFill>
@@ -9754,7 +9747,7 @@
               </a:spcAft>
             </a:pPr>
             <a:r>
-              <a:rPr sz="900" b="0" i="0">
+              <a:rPr sz="900" b="0" i="0" dirty="0">
                 <a:solidFill>
                   <a:srgbClr val="1A1A1A"/>
                 </a:solidFill>
@@ -9773,7 +9766,7 @@
               </a:spcAft>
             </a:pPr>
             <a:r>
-              <a:rPr sz="900" b="0" i="0">
+              <a:rPr sz="900" b="0" i="0" dirty="0">
                 <a:solidFill>
                   <a:srgbClr val="1A1A1A"/>
                 </a:solidFill>
@@ -9792,7 +9785,7 @@
               </a:spcAft>
             </a:pPr>
             <a:r>
-              <a:rPr sz="900" b="0" i="0">
+              <a:rPr sz="900" b="0" i="0" dirty="0">
                 <a:solidFill>
                   <a:srgbClr val="1A1A1A"/>
                 </a:solidFill>
@@ -9822,14 +9815,32 @@
                 <a:tableStyleId>{5C22544A-7EE6-4342-B048-85BDC9FD1C3A}</a:tableStyleId>
               </a:tblPr>
               <a:tblGrid>
-                <a:gridCol w="1500000"/>
-                <a:gridCol w="3300000"/>
-                <a:gridCol w="3708796"/>
+                <a:gridCol w="1500000">
+                  <a:extLst>
+                    <a:ext uri="{9D8B030D-6E8A-4147-A177-3AD203B41FA5}">
+                      <a16:colId xmlns:a16="http://schemas.microsoft.com/office/drawing/2014/main" val="20000"/>
+                    </a:ext>
+                  </a:extLst>
+                </a:gridCol>
+                <a:gridCol w="3300000">
+                  <a:extLst>
+                    <a:ext uri="{9D8B030D-6E8A-4147-A177-3AD203B41FA5}">
+                      <a16:colId xmlns:a16="http://schemas.microsoft.com/office/drawing/2014/main" val="20001"/>
+                    </a:ext>
+                  </a:extLst>
+                </a:gridCol>
+                <a:gridCol w="3708796">
+                  <a:extLst>
+                    <a:ext uri="{9D8B030D-6E8A-4147-A177-3AD203B41FA5}">
+                      <a16:colId xmlns:a16="http://schemas.microsoft.com/office/drawing/2014/main" val="20002"/>
+                    </a:ext>
+                  </a:extLst>
+                </a:gridCol>
               </a:tblGrid>
               <a:tr h="260000">
                 <a:tc>
                   <a:txBody>
-                    <a:bodyPr wrap="square"/>
+                    <a:bodyPr/>
                     <a:lstStyle/>
                     <a:p>
                       <a:pPr algn="l"/>
@@ -9852,7 +9863,7 @@
                 </a:tc>
                 <a:tc>
                   <a:txBody>
-                    <a:bodyPr wrap="square"/>
+                    <a:bodyPr/>
                     <a:lstStyle/>
                     <a:p>
                       <a:pPr algn="l"/>
@@ -9875,7 +9886,7 @@
                 </a:tc>
                 <a:tc>
                   <a:txBody>
-                    <a:bodyPr wrap="square"/>
+                    <a:bodyPr/>
                     <a:lstStyle/>
                     <a:p>
                       <a:pPr algn="l"/>
@@ -9896,11 +9907,16 @@
                     </a:solidFill>
                   </a:tcPr>
                 </a:tc>
+                <a:extLst>
+                  <a:ext uri="{0D108BD9-81ED-4DB2-BD59-A6C34878D82A}">
+                    <a16:rowId xmlns:a16="http://schemas.microsoft.com/office/drawing/2014/main" val="10000"/>
+                  </a:ext>
+                </a:extLst>
               </a:tr>
               <a:tr h="315000">
                 <a:tc>
                   <a:txBody>
-                    <a:bodyPr wrap="square"/>
+                    <a:bodyPr/>
                     <a:lstStyle/>
                     <a:p>
                       <a:pPr algn="l"/>
@@ -9923,7 +9939,7 @@
                 </a:tc>
                 <a:tc>
                   <a:txBody>
-                    <a:bodyPr wrap="square"/>
+                    <a:bodyPr/>
                     <a:lstStyle/>
                     <a:p>
                       <a:pPr algn="l"/>
@@ -9946,7 +9962,7 @@
                 </a:tc>
                 <a:tc>
                   <a:txBody>
-                    <a:bodyPr wrap="square"/>
+                    <a:bodyPr/>
                     <a:lstStyle/>
                     <a:p>
                       <a:pPr algn="l"/>
@@ -9967,11 +9983,16 @@
                     </a:solidFill>
                   </a:tcPr>
                 </a:tc>
+                <a:extLst>
+                  <a:ext uri="{0D108BD9-81ED-4DB2-BD59-A6C34878D82A}">
+                    <a16:rowId xmlns:a16="http://schemas.microsoft.com/office/drawing/2014/main" val="10001"/>
+                  </a:ext>
+                </a:extLst>
               </a:tr>
               <a:tr h="315000">
                 <a:tc>
                   <a:txBody>
-                    <a:bodyPr wrap="square"/>
+                    <a:bodyPr/>
                     <a:lstStyle/>
                     <a:p>
                       <a:pPr algn="l"/>
@@ -9994,7 +10015,7 @@
                 </a:tc>
                 <a:tc>
                   <a:txBody>
-                    <a:bodyPr wrap="square"/>
+                    <a:bodyPr/>
                     <a:lstStyle/>
                     <a:p>
                       <a:pPr algn="l"/>
@@ -10017,7 +10038,7 @@
                 </a:tc>
                 <a:tc>
                   <a:txBody>
-                    <a:bodyPr wrap="square"/>
+                    <a:bodyPr/>
                     <a:lstStyle/>
                     <a:p>
                       <a:pPr algn="l"/>
@@ -10038,11 +10059,16 @@
                     </a:solidFill>
                   </a:tcPr>
                 </a:tc>
+                <a:extLst>
+                  <a:ext uri="{0D108BD9-81ED-4DB2-BD59-A6C34878D82A}">
+                    <a16:rowId xmlns:a16="http://schemas.microsoft.com/office/drawing/2014/main" val="10002"/>
+                  </a:ext>
+                </a:extLst>
               </a:tr>
               <a:tr h="315000">
                 <a:tc>
                   <a:txBody>
-                    <a:bodyPr wrap="square"/>
+                    <a:bodyPr/>
                     <a:lstStyle/>
                     <a:p>
                       <a:pPr algn="l"/>
@@ -10065,7 +10091,7 @@
                 </a:tc>
                 <a:tc>
                   <a:txBody>
-                    <a:bodyPr wrap="square"/>
+                    <a:bodyPr/>
                     <a:lstStyle/>
                     <a:p>
                       <a:pPr algn="l"/>
@@ -10088,7 +10114,7 @@
                 </a:tc>
                 <a:tc>
                   <a:txBody>
-                    <a:bodyPr wrap="square"/>
+                    <a:bodyPr/>
                     <a:lstStyle/>
                     <a:p>
                       <a:pPr algn="l"/>
@@ -10109,11 +10135,16 @@
                     </a:solidFill>
                   </a:tcPr>
                 </a:tc>
+                <a:extLst>
+                  <a:ext uri="{0D108BD9-81ED-4DB2-BD59-A6C34878D82A}">
+                    <a16:rowId xmlns:a16="http://schemas.microsoft.com/office/drawing/2014/main" val="10003"/>
+                  </a:ext>
+                </a:extLst>
               </a:tr>
               <a:tr h="315000">
                 <a:tc>
                   <a:txBody>
-                    <a:bodyPr wrap="square"/>
+                    <a:bodyPr/>
                     <a:lstStyle/>
                     <a:p>
                       <a:pPr algn="l"/>
@@ -10136,7 +10167,7 @@
                 </a:tc>
                 <a:tc>
                   <a:txBody>
-                    <a:bodyPr wrap="square"/>
+                    <a:bodyPr/>
                     <a:lstStyle/>
                     <a:p>
                       <a:pPr algn="l"/>
@@ -10159,7 +10190,7 @@
                 </a:tc>
                 <a:tc>
                   <a:txBody>
-                    <a:bodyPr wrap="square"/>
+                    <a:bodyPr/>
                     <a:lstStyle/>
                     <a:p>
                       <a:pPr algn="l"/>
@@ -10180,11 +10211,16 @@
                     </a:solidFill>
                   </a:tcPr>
                 </a:tc>
+                <a:extLst>
+                  <a:ext uri="{0D108BD9-81ED-4DB2-BD59-A6C34878D82A}">
+                    <a16:rowId xmlns:a16="http://schemas.microsoft.com/office/drawing/2014/main" val="10004"/>
+                  </a:ext>
+                </a:extLst>
               </a:tr>
               <a:tr h="315000">
                 <a:tc>
                   <a:txBody>
-                    <a:bodyPr wrap="square"/>
+                    <a:bodyPr/>
                     <a:lstStyle/>
                     <a:p>
                       <a:pPr algn="l"/>
@@ -10207,7 +10243,7 @@
                 </a:tc>
                 <a:tc>
                   <a:txBody>
-                    <a:bodyPr wrap="square"/>
+                    <a:bodyPr/>
                     <a:lstStyle/>
                     <a:p>
                       <a:pPr algn="l"/>
@@ -10230,7 +10266,7 @@
                 </a:tc>
                 <a:tc>
                   <a:txBody>
-                    <a:bodyPr wrap="square"/>
+                    <a:bodyPr/>
                     <a:lstStyle/>
                     <a:p>
                       <a:pPr algn="l"/>
@@ -10251,11 +10287,16 @@
                     </a:solidFill>
                   </a:tcPr>
                 </a:tc>
+                <a:extLst>
+                  <a:ext uri="{0D108BD9-81ED-4DB2-BD59-A6C34878D82A}">
+                    <a16:rowId xmlns:a16="http://schemas.microsoft.com/office/drawing/2014/main" val="10005"/>
+                  </a:ext>
+                </a:extLst>
               </a:tr>
               <a:tr h="315000">
                 <a:tc>
                   <a:txBody>
-                    <a:bodyPr wrap="square"/>
+                    <a:bodyPr/>
                     <a:lstStyle/>
                     <a:p>
                       <a:pPr algn="l"/>
@@ -10278,7 +10319,7 @@
                 </a:tc>
                 <a:tc>
                   <a:txBody>
-                    <a:bodyPr wrap="square"/>
+                    <a:bodyPr/>
                     <a:lstStyle/>
                     <a:p>
                       <a:pPr algn="l"/>
@@ -10301,7 +10342,7 @@
                 </a:tc>
                 <a:tc>
                   <a:txBody>
-                    <a:bodyPr wrap="square"/>
+                    <a:bodyPr/>
                     <a:lstStyle/>
                     <a:p>
                       <a:pPr algn="l"/>
@@ -10322,6 +10363,11 @@
                     </a:solidFill>
                   </a:tcPr>
                 </a:tc>
+                <a:extLst>
+                  <a:ext uri="{0D108BD9-81ED-4DB2-BD59-A6C34878D82A}">
+                    <a16:rowId xmlns:a16="http://schemas.microsoft.com/office/drawing/2014/main" val="10006"/>
+                  </a:ext>
+                </a:extLst>
               </a:tr>
             </a:tbl>
           </a:graphicData>
@@ -11235,14 +11281,32 @@
                 <a:tableStyleId>{5C22544A-7EE6-4342-B048-85BDC9FD1C3A}</a:tableStyleId>
               </a:tblPr>
               <a:tblGrid>
-                <a:gridCol w="3200000"/>
-                <a:gridCol w="2400000"/>
-                <a:gridCol w="2908796"/>
+                <a:gridCol w="3200000">
+                  <a:extLst>
+                    <a:ext uri="{9D8B030D-6E8A-4147-A177-3AD203B41FA5}">
+                      <a16:colId xmlns:a16="http://schemas.microsoft.com/office/drawing/2014/main" val="20000"/>
+                    </a:ext>
+                  </a:extLst>
+                </a:gridCol>
+                <a:gridCol w="2400000">
+                  <a:extLst>
+                    <a:ext uri="{9D8B030D-6E8A-4147-A177-3AD203B41FA5}">
+                      <a16:colId xmlns:a16="http://schemas.microsoft.com/office/drawing/2014/main" val="20001"/>
+                    </a:ext>
+                  </a:extLst>
+                </a:gridCol>
+                <a:gridCol w="2908796">
+                  <a:extLst>
+                    <a:ext uri="{9D8B030D-6E8A-4147-A177-3AD203B41FA5}">
+                      <a16:colId xmlns:a16="http://schemas.microsoft.com/office/drawing/2014/main" val="20002"/>
+                    </a:ext>
+                  </a:extLst>
+                </a:gridCol>
               </a:tblGrid>
               <a:tr h="230000">
                 <a:tc>
                   <a:txBody>
-                    <a:bodyPr wrap="square"/>
+                    <a:bodyPr/>
                     <a:lstStyle/>
                     <a:p>
                       <a:pPr algn="l"/>
@@ -11265,7 +11329,7 @@
                 </a:tc>
                 <a:tc>
                   <a:txBody>
-                    <a:bodyPr wrap="square"/>
+                    <a:bodyPr/>
                     <a:lstStyle/>
                     <a:p>
                       <a:pPr algn="l"/>
@@ -11288,7 +11352,7 @@
                 </a:tc>
                 <a:tc>
                   <a:txBody>
-                    <a:bodyPr wrap="square"/>
+                    <a:bodyPr/>
                     <a:lstStyle/>
                     <a:p>
                       <a:pPr algn="l"/>
@@ -11309,11 +11373,16 @@
                     </a:solidFill>
                   </a:tcPr>
                 </a:tc>
+                <a:extLst>
+                  <a:ext uri="{0D108BD9-81ED-4DB2-BD59-A6C34878D82A}">
+                    <a16:rowId xmlns:a16="http://schemas.microsoft.com/office/drawing/2014/main" val="10000"/>
+                  </a:ext>
+                </a:extLst>
               </a:tr>
               <a:tr h="260000">
                 <a:tc>
                   <a:txBody>
-                    <a:bodyPr wrap="square"/>
+                    <a:bodyPr/>
                     <a:lstStyle/>
                     <a:p>
                       <a:pPr algn="l"/>
@@ -11336,7 +11405,7 @@
                 </a:tc>
                 <a:tc>
                   <a:txBody>
-                    <a:bodyPr wrap="square"/>
+                    <a:bodyPr/>
                     <a:lstStyle/>
                     <a:p>
                       <a:pPr algn="l"/>
@@ -11359,7 +11428,7 @@
                 </a:tc>
                 <a:tc>
                   <a:txBody>
-                    <a:bodyPr wrap="square"/>
+                    <a:bodyPr/>
                     <a:lstStyle/>
                     <a:p>
                       <a:pPr algn="l"/>
@@ -11380,11 +11449,16 @@
                     </a:solidFill>
                   </a:tcPr>
                 </a:tc>
+                <a:extLst>
+                  <a:ext uri="{0D108BD9-81ED-4DB2-BD59-A6C34878D82A}">
+                    <a16:rowId xmlns:a16="http://schemas.microsoft.com/office/drawing/2014/main" val="10001"/>
+                  </a:ext>
+                </a:extLst>
               </a:tr>
               <a:tr h="260000">
                 <a:tc>
                   <a:txBody>
-                    <a:bodyPr wrap="square"/>
+                    <a:bodyPr/>
                     <a:lstStyle/>
                     <a:p>
                       <a:pPr algn="l"/>
@@ -11407,7 +11481,7 @@
                 </a:tc>
                 <a:tc>
                   <a:txBody>
-                    <a:bodyPr wrap="square"/>
+                    <a:bodyPr/>
                     <a:lstStyle/>
                     <a:p>
                       <a:pPr algn="l"/>
@@ -11430,7 +11504,7 @@
                 </a:tc>
                 <a:tc>
                   <a:txBody>
-                    <a:bodyPr wrap="square"/>
+                    <a:bodyPr/>
                     <a:lstStyle/>
                     <a:p>
                       <a:pPr algn="l"/>
@@ -11451,11 +11525,16 @@
                     </a:solidFill>
                   </a:tcPr>
                 </a:tc>
+                <a:extLst>
+                  <a:ext uri="{0D108BD9-81ED-4DB2-BD59-A6C34878D82A}">
+                    <a16:rowId xmlns:a16="http://schemas.microsoft.com/office/drawing/2014/main" val="10002"/>
+                  </a:ext>
+                </a:extLst>
               </a:tr>
               <a:tr h="260000">
                 <a:tc>
                   <a:txBody>
-                    <a:bodyPr wrap="square"/>
+                    <a:bodyPr/>
                     <a:lstStyle/>
                     <a:p>
                       <a:pPr algn="l"/>
@@ -11478,7 +11557,7 @@
                 </a:tc>
                 <a:tc>
                   <a:txBody>
-                    <a:bodyPr wrap="square"/>
+                    <a:bodyPr/>
                     <a:lstStyle/>
                     <a:p>
                       <a:pPr algn="l"/>
@@ -11501,7 +11580,7 @@
                 </a:tc>
                 <a:tc>
                   <a:txBody>
-                    <a:bodyPr wrap="square"/>
+                    <a:bodyPr/>
                     <a:lstStyle/>
                     <a:p>
                       <a:pPr algn="l"/>
@@ -11522,11 +11601,16 @@
                     </a:solidFill>
                   </a:tcPr>
                 </a:tc>
+                <a:extLst>
+                  <a:ext uri="{0D108BD9-81ED-4DB2-BD59-A6C34878D82A}">
+                    <a16:rowId xmlns:a16="http://schemas.microsoft.com/office/drawing/2014/main" val="10003"/>
+                  </a:ext>
+                </a:extLst>
               </a:tr>
               <a:tr h="260000">
                 <a:tc>
                   <a:txBody>
-                    <a:bodyPr wrap="square"/>
+                    <a:bodyPr/>
                     <a:lstStyle/>
                     <a:p>
                       <a:pPr algn="l"/>
@@ -11549,7 +11633,7 @@
                 </a:tc>
                 <a:tc>
                   <a:txBody>
-                    <a:bodyPr wrap="square"/>
+                    <a:bodyPr/>
                     <a:lstStyle/>
                     <a:p>
                       <a:pPr algn="l"/>
@@ -11572,7 +11656,7 @@
                 </a:tc>
                 <a:tc>
                   <a:txBody>
-                    <a:bodyPr wrap="square"/>
+                    <a:bodyPr/>
                     <a:lstStyle/>
                     <a:p>
                       <a:pPr algn="l"/>
@@ -11593,11 +11677,16 @@
                     </a:solidFill>
                   </a:tcPr>
                 </a:tc>
+                <a:extLst>
+                  <a:ext uri="{0D108BD9-81ED-4DB2-BD59-A6C34878D82A}">
+                    <a16:rowId xmlns:a16="http://schemas.microsoft.com/office/drawing/2014/main" val="10004"/>
+                  </a:ext>
+                </a:extLst>
               </a:tr>
               <a:tr h="260000">
                 <a:tc>
                   <a:txBody>
-                    <a:bodyPr wrap="square"/>
+                    <a:bodyPr/>
                     <a:lstStyle/>
                     <a:p>
                       <a:pPr algn="l"/>
@@ -11620,7 +11709,7 @@
                 </a:tc>
                 <a:tc>
                   <a:txBody>
-                    <a:bodyPr wrap="square"/>
+                    <a:bodyPr/>
                     <a:lstStyle/>
                     <a:p>
                       <a:pPr algn="l"/>
@@ -11643,7 +11732,7 @@
                 </a:tc>
                 <a:tc>
                   <a:txBody>
-                    <a:bodyPr wrap="square"/>
+                    <a:bodyPr/>
                     <a:lstStyle/>
                     <a:p>
                       <a:pPr algn="l"/>
@@ -11664,11 +11753,16 @@
                     </a:solidFill>
                   </a:tcPr>
                 </a:tc>
+                <a:extLst>
+                  <a:ext uri="{0D108BD9-81ED-4DB2-BD59-A6C34878D82A}">
+                    <a16:rowId xmlns:a16="http://schemas.microsoft.com/office/drawing/2014/main" val="10005"/>
+                  </a:ext>
+                </a:extLst>
               </a:tr>
               <a:tr h="260000">
                 <a:tc>
                   <a:txBody>
-                    <a:bodyPr wrap="square"/>
+                    <a:bodyPr/>
                     <a:lstStyle/>
                     <a:p>
                       <a:pPr algn="l"/>
@@ -11691,7 +11785,7 @@
                 </a:tc>
                 <a:tc>
                   <a:txBody>
-                    <a:bodyPr wrap="square"/>
+                    <a:bodyPr/>
                     <a:lstStyle/>
                     <a:p>
                       <a:pPr algn="l"/>
@@ -11714,7 +11808,7 @@
                 </a:tc>
                 <a:tc>
                   <a:txBody>
-                    <a:bodyPr wrap="square"/>
+                    <a:bodyPr/>
                     <a:lstStyle/>
                     <a:p>
                       <a:pPr algn="l"/>
@@ -11735,6 +11829,11 @@
                     </a:solidFill>
                   </a:tcPr>
                 </a:tc>
+                <a:extLst>
+                  <a:ext uri="{0D108BD9-81ED-4DB2-BD59-A6C34878D82A}">
+                    <a16:rowId xmlns:a16="http://schemas.microsoft.com/office/drawing/2014/main" val="10006"/>
+                  </a:ext>
+                </a:extLst>
               </a:tr>
             </a:tbl>
           </a:graphicData>
@@ -11948,7 +12047,7 @@
               </a:spcAft>
             </a:pPr>
             <a:r>
-              <a:rPr sz="1100" b="1" i="0">
+              <a:rPr sz="1100" b="1" i="0" dirty="0">
                 <a:solidFill>
                   <a:srgbClr val="1E8E3E"/>
                 </a:solidFill>
@@ -11967,7 +12066,7 @@
               </a:spcAft>
             </a:pPr>
             <a:r>
-              <a:rPr sz="900" b="0" i="0">
+              <a:rPr sz="900" b="0" i="0" dirty="0">
                 <a:solidFill>
                   <a:srgbClr val="1A1A1A"/>
                 </a:solidFill>
@@ -11986,7 +12085,7 @@
               </a:spcAft>
             </a:pPr>
             <a:r>
-              <a:rPr sz="900" b="0" i="0">
+              <a:rPr sz="900" b="0" i="0" dirty="0">
                 <a:solidFill>
                   <a:srgbClr val="1A1A1A"/>
                 </a:solidFill>
@@ -12005,7 +12104,7 @@
               </a:spcAft>
             </a:pPr>
             <a:r>
-              <a:rPr sz="900" b="0" i="0">
+              <a:rPr sz="900" b="0" i="0" dirty="0">
                 <a:solidFill>
                   <a:srgbClr val="1A1A1A"/>
                 </a:solidFill>
@@ -12024,7 +12123,7 @@
               </a:spcAft>
             </a:pPr>
             <a:r>
-              <a:rPr sz="900" b="0" i="0">
+              <a:rPr sz="900" b="0" i="0" dirty="0">
                 <a:solidFill>
                   <a:srgbClr val="1A1A1A"/>
                 </a:solidFill>
@@ -12043,7 +12142,7 @@
               </a:spcAft>
             </a:pPr>
             <a:r>
-              <a:rPr sz="900" b="0" i="0">
+              <a:rPr sz="900" b="0" i="0" dirty="0">
                 <a:solidFill>
                   <a:srgbClr val="1A1A1A"/>
                 </a:solidFill>
@@ -12062,7 +12161,7 @@
               </a:spcAft>
             </a:pPr>
             <a:r>
-              <a:rPr sz="900" b="0" i="0">
+              <a:rPr sz="900" b="0" i="0" dirty="0">
                 <a:solidFill>
                   <a:srgbClr val="1A1A1A"/>
                 </a:solidFill>
@@ -12081,7 +12180,7 @@
               </a:spcAft>
             </a:pPr>
             <a:r>
-              <a:rPr sz="900" b="0" i="0">
+              <a:rPr sz="900" b="0" i="0" dirty="0">
                 <a:solidFill>
                   <a:srgbClr val="1A1A1A"/>
                 </a:solidFill>
@@ -12100,7 +12199,7 @@
               </a:spcAft>
             </a:pPr>
             <a:r>
-              <a:rPr sz="1100" b="1" i="0">
+              <a:rPr sz="1100" b="1" i="0" dirty="0">
                 <a:solidFill>
                   <a:srgbClr val="1E8E3E"/>
                 </a:solidFill>
@@ -12119,13 +12218,31 @@
               </a:spcAft>
             </a:pPr>
             <a:r>
-              <a:rPr sz="900" b="0" i="0">
+              <a:rPr sz="900" b="0" i="0" dirty="0">
                 <a:solidFill>
                   <a:srgbClr val="1A1A1A"/>
                 </a:solidFill>
                 <a:latin typeface="Google Sans Flex"/>
               </a:rPr>
-              <a:t>•  7-day risk escalation forecast across 8 monitored cities (OpenWeatherMap)</a:t>
+              <a:t>•  7-day risk escalation forecast across 8 monitored cities (</a:t>
+            </a:r>
+            <a:r>
+              <a:rPr sz="900" b="0" i="0" dirty="0" err="1">
+                <a:solidFill>
+                  <a:srgbClr val="1A1A1A"/>
+                </a:solidFill>
+                <a:latin typeface="Google Sans Flex"/>
+              </a:rPr>
+              <a:t>OpenWeatherMap</a:t>
+            </a:r>
+            <a:r>
+              <a:rPr sz="900" b="0" i="0" dirty="0">
+                <a:solidFill>
+                  <a:srgbClr val="1A1A1A"/>
+                </a:solidFill>
+                <a:latin typeface="Google Sans Flex"/>
+              </a:rPr>
+              <a:t>)</a:t>
             </a:r>
           </a:p>
           <a:p>
@@ -12138,7 +12255,7 @@
               </a:spcAft>
             </a:pPr>
             <a:r>
-              <a:rPr sz="900" b="0" i="0">
+              <a:rPr sz="900" b="0" i="0" dirty="0">
                 <a:solidFill>
                   <a:srgbClr val="1A1A1A"/>
                 </a:solidFill>
@@ -12157,7 +12274,7 @@
               </a:spcAft>
             </a:pPr>
             <a:r>
-              <a:rPr sz="900" b="0" i="0">
+              <a:rPr sz="900" b="0" i="0" dirty="0">
                 <a:solidFill>
                   <a:srgbClr val="1A1A1A"/>
                 </a:solidFill>
@@ -12176,7 +12293,7 @@
               </a:spcAft>
             </a:pPr>
             <a:r>
-              <a:rPr sz="900" b="0" i="0">
+              <a:rPr sz="900" b="0" i="0" dirty="0">
                 <a:solidFill>
                   <a:srgbClr val="1A1A1A"/>
                 </a:solidFill>
@@ -12195,7 +12312,7 @@
               </a:spcAft>
             </a:pPr>
             <a:r>
-              <a:rPr sz="900" b="0" i="0">
+              <a:rPr sz="900" b="0" i="0" dirty="0">
                 <a:solidFill>
                   <a:srgbClr val="1A1A1A"/>
                 </a:solidFill>
@@ -12214,7 +12331,7 @@
               </a:spcAft>
             </a:pPr>
             <a:r>
-              <a:rPr sz="1100" b="1" i="0">
+              <a:rPr sz="1100" b="1" i="0" dirty="0">
                 <a:solidFill>
                   <a:srgbClr val="1857B8"/>
                 </a:solidFill>
@@ -12233,7 +12350,7 @@
               </a:spcAft>
             </a:pPr>
             <a:r>
-              <a:rPr sz="900" b="0" i="0">
+              <a:rPr sz="900" b="0" i="0" dirty="0">
                 <a:solidFill>
                   <a:srgbClr val="1A1A1A"/>
                 </a:solidFill>
@@ -12252,7 +12369,7 @@
               </a:spcAft>
             </a:pPr>
             <a:r>
-              <a:rPr sz="900" b="0" i="0">
+              <a:rPr sz="900" b="0" i="0" dirty="0">
                 <a:solidFill>
                   <a:srgbClr val="1A1A1A"/>
                 </a:solidFill>
@@ -12271,7 +12388,7 @@
               </a:spcAft>
             </a:pPr>
             <a:r>
-              <a:rPr sz="1100" b="1" i="0">
+              <a:rPr sz="1100" b="1" i="0" dirty="0">
                 <a:solidFill>
                   <a:srgbClr val="B86E00"/>
                 </a:solidFill>
@@ -12290,7 +12407,7 @@
               </a:spcAft>
             </a:pPr>
             <a:r>
-              <a:rPr sz="900" b="0" i="0">
+              <a:rPr sz="900" b="0" i="0" dirty="0">
                 <a:solidFill>
                   <a:srgbClr val="1A1A1A"/>
                 </a:solidFill>
@@ -12309,7 +12426,7 @@
               </a:spcAft>
             </a:pPr>
             <a:r>
-              <a:rPr sz="900" b="0" i="0">
+              <a:rPr sz="900" b="0" i="0" dirty="0">
                 <a:solidFill>
                   <a:srgbClr val="1A1A1A"/>
                 </a:solidFill>
@@ -12492,102 +12609,36 @@
           </a:p>
         </p:txBody>
       </p:sp>
-      <p:sp>
-        <p:nvSpPr>
-          <p:cNvPr id="96" name="TextBox 95"/>
-          <p:cNvSpPr txBox="1"/>
+      <p:pic>
+        <p:nvPicPr>
+          <p:cNvPr id="3" name="Picture 2">
+            <a:extLst>
+              <a:ext uri="{FF2B5EF4-FFF2-40B4-BE49-F238E27FC236}">
+                <a16:creationId xmlns:a16="http://schemas.microsoft.com/office/drawing/2014/main" id="{6DEE5C0A-4F6A-2008-2DA9-A7FB65808716}"/>
+              </a:ext>
+            </a:extLst>
+          </p:cNvPr>
+          <p:cNvPicPr>
+            <a:picLocks noChangeAspect="1"/>
+          </p:cNvPicPr>
           <p:nvPr/>
-        </p:nvSpPr>
+        </p:nvPicPr>
+        <p:blipFill>
+          <a:blip r:embed="rId5"/>
+          <a:stretch>
+            <a:fillRect/>
+          </a:stretch>
+        </p:blipFill>
         <p:spPr>
           <a:xfrm>
-            <a:off x="265350" y="1150000"/>
-            <a:ext cx="8613300" cy="3920000"/>
+            <a:off x="404950" y="217868"/>
+            <a:ext cx="7922622" cy="5143500"/>
           </a:xfrm>
           <a:prstGeom prst="rect">
             <a:avLst/>
           </a:prstGeom>
-          <a:noFill/>
         </p:spPr>
-        <p:txBody>
-          <a:bodyPr wrap="square">
-            <a:spAutoFit/>
-          </a:bodyPr>
-          <a:lstStyle/>
-          <a:p>
-            <a:pPr>
-              <a:spcBef>
-                <a:spcPts val="200"/>
-              </a:spcBef>
-              <a:spcAft>
-                <a:spcPts val="300"/>
-              </a:spcAft>
-            </a:pPr>
-            <a:r>
-              <a:rPr sz="1100" b="1" i="0">
-                <a:solidFill>
-                  <a:srgbClr val="1A1A1A"/>
-                </a:solidFill>
-                <a:latin typeface="Google Sans Flex Medium"/>
-              </a:rPr>
-              <a:t>How an incident moves through TerraGrid today</a:t>
-            </a:r>
-          </a:p>
-          <a:p>
-            <a:pPr>
-              <a:lnSpc>
-                <a:spcPct val="88000"/>
-              </a:lnSpc>
-              <a:spcBef>
-                <a:spcPts val="100"/>
-              </a:spcBef>
-            </a:pPr>
-            <a:r>
-              <a:rPr sz="680" b="0" i="0">
-                <a:solidFill>
-                  <a:srgbClr val="1A1A1A"/>
-                </a:solidFill>
-                <a:latin typeface="Courier New"/>
-              </a:rPr>
-              <a:t>┌────────────────────────┐   ┌───────────────────────────────┐   ┌──────────────────────────┐
-│ EXTERNAL SOURCES         │─▶│ 1. DATA INGESTION                │─▶│ Incident record (PostgreSQL)│
-│ NASA EONET·USGS·NOAA·    │  │ Async poll + OSM infra lookup    │  └──────────────────────────┘
-│ GDACS·OpenWeatherMap     │  └───────────────────────────────┘
-└────────────────────────┘
-┌───────────────────────────────┐   Risk Escalation Timeline, Preparedness
-│ 2. PREPARE PHASE                 │─▶ Checklist, Agency Alert drafts
-│ 7-day forecast + AI Decision     │
-│ Support (Gemini 2.5 Flash)       │
-└───────────────────────────────┘
-┌───────────────────────────────┐   Dispatch recommendation, evac route
-│ 3. RESPONSE PHASE                 │─▶ (OSRM), WhatsApp / Email alert sent
-│ Live dashboard + evac routing     │
-│ + satellite cross-validation      │
-└───────────────────────────────┘
-┌───────────────────────────────┐   Raw API + Gemini response saved to
-│ 4. AUDIT TRAIL (every step)       │─▶ logs/ as a JSON envelope, folder
-│ data_logger.py cross-check        │   per source
-└───────────────────────────────┘
-</a:t>
-            </a:r>
-          </a:p>
-          <a:p>
-            <a:pPr>
-              <a:spcBef>
-                <a:spcPts val="800"/>
-              </a:spcBef>
-            </a:pPr>
-            <a:r>
-              <a:rPr sz="900" b="0" i="1">
-                <a:solidFill>
-                  <a:srgbClr val="B86E00"/>
-                </a:solidFill>
-                <a:latin typeface="Google Sans Flex"/>
-              </a:rPr>
-              <a:t>PREDICT (6-month early warning) and RECOVER (post-event damage assessment) are the next two phases on the roadmap — not part of this flow yet.</a:t>
-            </a:r>
-          </a:p>
-        </p:txBody>
-      </p:sp>
+      </p:pic>
     </p:spTree>
   </p:cSld>
   <p:clrMapOvr>
@@ -12888,7 +12939,7 @@
         </p:nvSpPr>
         <p:spPr>
           <a:xfrm>
-            <a:off x="265350" y="663825"/>
+            <a:off x="0" y="543420"/>
             <a:ext cx="8943000" cy="561900"/>
           </a:xfrm>
           <a:prstGeom prst="rect">
@@ -12915,7 +12966,7 @@
               <a:buNone/>
             </a:pPr>
             <a:r>
-              <a:rPr lang="en-GB" sz="1600">
+              <a:rPr lang="en-GB" sz="1600" dirty="0">
                 <a:latin typeface="Google Sans Flex Medium"/>
                 <a:ea typeface="Google Sans Flex Medium"/>
                 <a:cs typeface="Google Sans Flex Medium"/>
@@ -12923,7 +12974,7 @@
               </a:rPr>
               <a:t>Architecture diagram of the proposed solution</a:t>
             </a:r>
-            <a:endParaRPr sz="1600">
+            <a:endParaRPr sz="1600" dirty="0">
               <a:latin typeface="Google Sans Flex Medium"/>
               <a:ea typeface="Google Sans Flex Medium"/>
               <a:cs typeface="Google Sans Flex Medium"/>
@@ -12932,98 +12983,36 @@
           </a:p>
         </p:txBody>
       </p:sp>
-      <p:sp>
-        <p:nvSpPr>
-          <p:cNvPr id="112" name="TextBox 111"/>
-          <p:cNvSpPr txBox="1"/>
+      <p:pic>
+        <p:nvPicPr>
+          <p:cNvPr id="3" name="Picture 2">
+            <a:extLst>
+              <a:ext uri="{FF2B5EF4-FFF2-40B4-BE49-F238E27FC236}">
+                <a16:creationId xmlns:a16="http://schemas.microsoft.com/office/drawing/2014/main" id="{EFD26A76-2690-D696-EE09-2A0841D25CDD}"/>
+              </a:ext>
+            </a:extLst>
+          </p:cNvPr>
+          <p:cNvPicPr>
+            <a:picLocks noChangeAspect="1"/>
+          </p:cNvPicPr>
           <p:nvPr/>
-        </p:nvSpPr>
+        </p:nvPicPr>
+        <p:blipFill>
+          <a:blip r:embed="rId5"/>
+          <a:stretch>
+            <a:fillRect/>
+          </a:stretch>
+        </p:blipFill>
         <p:spPr>
           <a:xfrm>
-            <a:off x="265350" y="1180000"/>
-            <a:ext cx="8613300" cy="3860000"/>
+            <a:off x="0" y="1038496"/>
+            <a:ext cx="9144000" cy="3819253"/>
           </a:xfrm>
           <a:prstGeom prst="rect">
             <a:avLst/>
           </a:prstGeom>
-          <a:noFill/>
         </p:spPr>
-        <p:txBody>
-          <a:bodyPr wrap="square">
-            <a:spAutoFit/>
-          </a:bodyPr>
-          <a:lstStyle/>
-          <a:p>
-            <a:pPr>
-              <a:spcBef>
-                <a:spcPts val="200"/>
-              </a:spcBef>
-              <a:spcAft>
-                <a:spcPts val="400"/>
-              </a:spcAft>
-            </a:pPr>
-            <a:r>
-              <a:rPr sz="1100" b="1" i="0">
-                <a:solidFill>
-                  <a:srgbClr val="1A1A1A"/>
-                </a:solidFill>
-                <a:latin typeface="Google Sans Flex Medium"/>
-              </a:rPr>
-              <a:t>System Architecture (verified against the running codebase)</a:t>
-            </a:r>
-          </a:p>
-          <a:p>
-            <a:pPr>
-              <a:lnSpc>
-                <a:spcPct val="92000"/>
-              </a:lnSpc>
-              <a:spcBef>
-                <a:spcPts val="400"/>
-              </a:spcBef>
-            </a:pPr>
-            <a:r>
-              <a:rPr sz="700" b="0" i="0">
-                <a:solidFill>
-                  <a:srgbClr val="1A1A1A"/>
-                </a:solidFill>
-                <a:latin typeface="Courier New"/>
-              </a:rPr>
-              <a:t>┌───────────────────────┐   ┌─────────────────────────────┐   ┌───────────────────────────┐
-│   DATA SOURCES          │   │  BACKEND — FastAPI, Python 3.13 │   │ FRONTEND — Vue 3 + Vite     │
-│   NASA EONET · USGS     │──▶│  PostgreSQL (SQLAlchemy+Alembic)│──▶│ Pinia · Vue Router          │
-│   NOAA · GDACS           │   │  APScheduler background polling │   │ Mapbox GL live map          │
-│   OpenWeatherMap         │   │  WebSocket server (/ws/dashboard)│   │ WebSocket live updates      │
-│   OpenStreetMap/Overpass │   └───────────────┬──────────────────┘   │ i18n · mobile-responsive    │
-│   OSRM routing           │                   ▼                      └───────────────────────────┘
-└───────────────────────┘   ┌─────────────────────────────┐
-                              │  AI LAYER                      │   ┌───────────────────────────┐
-                              │  Vertex AI — Gemini 2.5 Flash  │──▶│  ALERTING                   │
-                              │  Google Earth Engine(Sentinel-1)│   │  WhatsApp (WAHA)            │
-                              │  Decision lineage / audit trail │   │  Email (Resend)              │
-                              └─────────────────────────────┘   └───────────────────────────┘
-TRACEABILITY: every external API call and every Gemini response is written to
-logs/data/&lt;source&gt;/ as a timestamped JSON envelope — a cross-check trail, not just a log line.
-</a:t>
-            </a:r>
-          </a:p>
-          <a:p>
-            <a:pPr>
-              <a:spcBef>
-                <a:spcPts val="600"/>
-              </a:spcBef>
-            </a:pPr>
-            <a:r>
-              <a:rPr sz="900" b="0" i="1">
-                <a:solidFill>
-                  <a:srgbClr val="5F5F5F"/>
-                </a:solidFill>
-                <a:latin typeface="Google Sans Flex"/>
-              </a:rPr>
-              <a:t>Deployment target: Google Cloud Run (backend) with Docker + GitHub Actions CI. Not yet deployed to production at submission time.</a:t>
-            </a:r>
-          </a:p>
-        </p:txBody>
-      </p:sp>
+      </p:pic>
     </p:spTree>
   </p:cSld>
   <p:clrMapOvr>

</xml_diff>